<commit_message>
sd-02-012: separate resolution from compression; device mapping is the source's simplified example
Lesson, figure and deck slides 2 and 8; PPTX re-exported.

Co-Authored-By: Claude Opus 5.5 <noreply@anthropic.com>
Claude-Session: https://claude.ai/code/session_01McBLtMnJbTnB94NeVs8a2V
</commit_message>
<xml_diff>
--- a/system-design-101/vi/lessons/sd-02-012/slides/sd-02-012.pptx
+++ b/system-design-101/vi/lessons/sd-02-012/slides/sd-02-012.pptx
@@ -4791,7 +4791,7 @@
               <a:t> nhiều</a:t>
             </a:r>
             <a:r>
-              <a:rPr lang="en-US" sz="6900" dirty="0" spc="-72" kern="0">
+              <a:rPr lang="en-US" sz="6900" dirty="0" spc="-3" kern="0">
                 <a:solidFill>
                   <a:srgbClr val="14161C"/>
                 </a:solidFill>
@@ -4799,10 +4799,10 @@
                 <a:ea typeface="Bricolage Grotesque ExtraBold" pitchFamily="34" charset="-122"/>
                 <a:cs typeface="Bricolage Grotesque ExtraBold" pitchFamily="34" charset="-120"/>
               </a:rPr>
-              <a:t> mức</a:t>
-            </a:r>
-            <a:r>
-              <a:rPr lang="en-US" sz="6900" dirty="0" spc="-1" kern="0">
+              <a:t> bản</a:t>
+            </a:r>
+            <a:r>
+              <a:rPr lang="en-US" sz="6900" dirty="0" spc="18" kern="0">
                 <a:solidFill>
                   <a:srgbClr val="14161C"/>
                 </a:solidFill>
@@ -4810,10 +4810,10 @@
                 <a:ea typeface="Bricolage Grotesque ExtraBold" pitchFamily="34" charset="-122"/>
                 <a:cs typeface="Bricolage Grotesque ExtraBold" pitchFamily="34" charset="-120"/>
               </a:rPr>
-              <a:t> cho</a:t>
-            </a:r>
-            <a:r>
-              <a:rPr lang="en-US" sz="6900" dirty="0" spc="9" kern="0">
+              <a:t> để</a:t>
+            </a:r>
+            <a:r>
+              <a:rPr lang="en-US" sz="6900" dirty="0" spc="0" kern="0">
                 <a:solidFill>
                   <a:srgbClr val="14161C"/>
                 </a:solidFill>
@@ -4821,18 +4821,7 @@
                 <a:ea typeface="Bricolage Grotesque ExtraBold" pitchFamily="34" charset="-122"/>
                 <a:cs typeface="Bricolage Grotesque ExtraBold" pitchFamily="34" charset="-120"/>
               </a:rPr>
-              <a:t> từng</a:t>
-            </a:r>
-            <a:r>
-              <a:rPr lang="en-US" sz="6900" dirty="0" spc="-2" kern="0">
-                <a:solidFill>
-                  <a:srgbClr val="14161C"/>
-                </a:solidFill>
-                <a:latin typeface="Bricolage Grotesque ExtraBold" pitchFamily="34" charset="0"/>
-                <a:ea typeface="Bricolage Grotesque ExtraBold" pitchFamily="34" charset="-122"/>
-                <a:cs typeface="Bricolage Grotesque ExtraBold" pitchFamily="34" charset="-120"/>
-              </a:rPr>
-              <a:t> máy</a:t>
+              <a:t> chọn</a:t>
             </a:r>
             <a:endParaRPr lang="en-US" sz="6900" dirty="0"/>
           </a:p>
@@ -4890,6 +4879,39 @@
               <a:buNone/>
             </a:pPr>
             <a:r>
+              <a:rPr lang="en-US" sz="1800" b="1" spc="226" kern="0" dirty="0">
+                <a:solidFill>
+                  <a:srgbClr val="6B6A66"/>
+                </a:solidFill>
+                <a:latin typeface="Be Vietnam Pro" pitchFamily="34" charset="0"/>
+                <a:ea typeface="Be Vietnam Pro" pitchFamily="34" charset="-122"/>
+                <a:cs typeface="Be Vietnam Pro" pitchFamily="34" charset="-120"/>
+              </a:rPr>
+              <a:t>VÍ</a:t>
+            </a:r>
+            <a:r>
+              <a:rPr lang="en-US" sz="1800" b="1" spc="228" kern="0" dirty="0">
+                <a:solidFill>
+                  <a:srgbClr val="6B6A66"/>
+                </a:solidFill>
+                <a:latin typeface="Be Vietnam Pro" pitchFamily="34" charset="0"/>
+                <a:ea typeface="Be Vietnam Pro" pitchFamily="34" charset="-122"/>
+                <a:cs typeface="Be Vietnam Pro" pitchFamily="34" charset="-120"/>
+              </a:rPr>
+              <a:t> DỤ</a:t>
+            </a:r>
+            <a:r>
+              <a:rPr lang="en-US" sz="1800" b="1" spc="225" kern="0" dirty="0">
+                <a:solidFill>
+                  <a:srgbClr val="6B6A66"/>
+                </a:solidFill>
+                <a:latin typeface="Be Vietnam Pro" pitchFamily="34" charset="0"/>
+                <a:ea typeface="Be Vietnam Pro" pitchFamily="34" charset="-122"/>
+                <a:cs typeface="Be Vietnam Pro" pitchFamily="34" charset="-120"/>
+              </a:rPr>
+              <a:t> ·</a:t>
+            </a:r>
+            <a:r>
               <a:rPr lang="en-US" sz="1800" b="1" spc="224" kern="0" dirty="0">
                 <a:solidFill>
                   <a:srgbClr val="6B6A66"/>
@@ -4898,7 +4920,7 @@
                 <a:ea typeface="Be Vietnam Pro" pitchFamily="34" charset="-122"/>
                 <a:cs typeface="Be Vietnam Pro" pitchFamily="34" charset="-120"/>
               </a:rPr>
-              <a:t>ĐIỆN</a:t>
+              <a:t> ĐIỆN</a:t>
             </a:r>
             <a:r>
               <a:rPr lang="en-US" sz="1800" b="1" spc="213" kern="0" dirty="0">
@@ -5006,7 +5028,7 @@
               <a:buNone/>
             </a:pPr>
             <a:r>
-              <a:rPr lang="en-US" sz="1800" b="1" spc="166" kern="0" dirty="0">
+              <a:rPr lang="en-US" sz="1800" b="1" spc="226" kern="0" dirty="0">
                 <a:solidFill>
                   <a:srgbClr val="6B6A66"/>
                 </a:solidFill>
@@ -5014,7 +5036,18 @@
                 <a:ea typeface="Be Vietnam Pro" pitchFamily="34" charset="-122"/>
                 <a:cs typeface="Be Vietnam Pro" pitchFamily="34" charset="-120"/>
               </a:rPr>
-              <a:t>MÁY</a:t>
+              <a:t>VÍ</a:t>
+            </a:r>
+            <a:r>
+              <a:rPr lang="en-US" sz="1800" b="1" spc="228" kern="0" dirty="0">
+                <a:solidFill>
+                  <a:srgbClr val="6B6A66"/>
+                </a:solidFill>
+                <a:latin typeface="Be Vietnam Pro" pitchFamily="34" charset="0"/>
+                <a:ea typeface="Be Vietnam Pro" pitchFamily="34" charset="-122"/>
+                <a:cs typeface="Be Vietnam Pro" pitchFamily="34" charset="-120"/>
+              </a:rPr>
+              <a:t> DỤ</a:t>
             </a:r>
             <a:r>
               <a:rPr lang="en-US" sz="1800" b="1" spc="225" kern="0" dirty="0">
@@ -5025,7 +5058,18 @@
                 <a:ea typeface="Be Vietnam Pro" pitchFamily="34" charset="-122"/>
                 <a:cs typeface="Be Vietnam Pro" pitchFamily="34" charset="-120"/>
               </a:rPr>
-              <a:t> TÍNH</a:t>
+              <a:t> ·</a:t>
+            </a:r>
+            <a:r>
+              <a:rPr lang="en-US" sz="1800" b="1" spc="181" kern="0" dirty="0">
+                <a:solidFill>
+                  <a:srgbClr val="6B6A66"/>
+                </a:solidFill>
+                <a:latin typeface="Be Vietnam Pro" pitchFamily="34" charset="0"/>
+                <a:ea typeface="Be Vietnam Pro" pitchFamily="34" charset="-122"/>
+                <a:cs typeface="Be Vietnam Pro" pitchFamily="34" charset="-120"/>
+              </a:rPr>
+              <a:t> MÁY</a:t>
             </a:r>
             <a:r>
               <a:rPr lang="en-US" sz="1800" b="1" spc="214" kern="0" dirty="0">
@@ -5139,7 +5183,7 @@
               <a:buNone/>
             </a:pPr>
             <a:r>
-              <a:rPr lang="en-US" sz="1800" b="1" spc="223" kern="0" dirty="0">
+              <a:rPr lang="en-US" sz="1800" b="1" spc="226" kern="0" dirty="0">
                 <a:solidFill>
                   <a:srgbClr val="F8D9D0"/>
                 </a:solidFill>
@@ -5147,7 +5191,40 @@
                 <a:ea typeface="Be Vietnam Pro" pitchFamily="34" charset="-122"/>
                 <a:cs typeface="Be Vietnam Pro" pitchFamily="34" charset="-120"/>
               </a:rPr>
-              <a:t>MÀN</a:t>
+              <a:t>VÍ</a:t>
+            </a:r>
+            <a:r>
+              <a:rPr lang="en-US" sz="1800" b="1" spc="228" kern="0" dirty="0">
+                <a:solidFill>
+                  <a:srgbClr val="F8D9D0"/>
+                </a:solidFill>
+                <a:latin typeface="Be Vietnam Pro" pitchFamily="34" charset="0"/>
+                <a:ea typeface="Be Vietnam Pro" pitchFamily="34" charset="-122"/>
+                <a:cs typeface="Be Vietnam Pro" pitchFamily="34" charset="-120"/>
+              </a:rPr>
+              <a:t> DỤ</a:t>
+            </a:r>
+            <a:r>
+              <a:rPr lang="en-US" sz="1800" b="1" spc="225" kern="0" dirty="0">
+                <a:solidFill>
+                  <a:srgbClr val="F8D9D0"/>
+                </a:solidFill>
+                <a:latin typeface="Be Vietnam Pro" pitchFamily="34" charset="0"/>
+                <a:ea typeface="Be Vietnam Pro" pitchFamily="34" charset="-122"/>
+                <a:cs typeface="Be Vietnam Pro" pitchFamily="34" charset="-120"/>
+              </a:rPr>
+              <a:t> ·</a:t>
+            </a:r>
+            <a:r>
+              <a:rPr lang="en-US" sz="1800" b="1" spc="224" kern="0" dirty="0">
+                <a:solidFill>
+                  <a:srgbClr val="F8D9D0"/>
+                </a:solidFill>
+                <a:latin typeface="Be Vietnam Pro" pitchFamily="34" charset="0"/>
+                <a:ea typeface="Be Vietnam Pro" pitchFamily="34" charset="-122"/>
+                <a:cs typeface="Be Vietnam Pro" pitchFamily="34" charset="-120"/>
+              </a:rPr>
+              <a:t> MÀN</a:t>
             </a:r>
             <a:r>
               <a:rPr lang="en-US" sz="1800" b="1" spc="227" kern="0" dirty="0">
@@ -5242,7 +5319,7 @@
               <a:buNone/>
             </a:pPr>
             <a:r>
-              <a:rPr lang="en-US" sz="2550" dirty="0" spc="-14" kern="0">
+              <a:rPr lang="en-US" sz="2550" dirty="0" spc="2" kern="0">
                 <a:solidFill>
                   <a:srgbClr val="14161C"/>
                 </a:solidFill>
@@ -5250,10 +5327,10 @@
                 <a:ea typeface="Be Vietnam Pro" pitchFamily="34" charset="-122"/>
                 <a:cs typeface="Be Vietnam Pro" pitchFamily="34" charset="-120"/>
               </a:rPr>
-              <a:t>Chuyển</a:t>
-            </a:r>
-            <a:r>
-              <a:rPr lang="en-US" sz="2550" dirty="0" spc="2" kern="0">
+              <a:t>Ví</a:t>
+            </a:r>
+            <a:r>
+              <a:rPr lang="en-US" sz="2550" dirty="0" spc="-2" kern="0">
                 <a:solidFill>
                   <a:srgbClr val="14161C"/>
                 </a:solidFill>
@@ -5261,10 +5338,10 @@
                 <a:ea typeface="Be Vietnam Pro" pitchFamily="34" charset="-122"/>
                 <a:cs typeface="Be Vietnam Pro" pitchFamily="34" charset="-120"/>
               </a:rPr>
-              <a:t> mã</a:t>
-            </a:r>
-            <a:r>
-              <a:rPr lang="en-US" sz="2550" dirty="0" spc="-2" kern="0">
+              <a:t> dụ của</a:t>
+            </a:r>
+            <a:r>
+              <a:rPr lang="en-US" sz="2550" dirty="0" spc="1" kern="0">
                 <a:solidFill>
                   <a:srgbClr val="14161C"/>
                 </a:solidFill>
@@ -5272,7 +5349,62 @@
                 <a:ea typeface="Be Vietnam Pro" pitchFamily="34" charset="-122"/>
                 <a:cs typeface="Be Vietnam Pro" pitchFamily="34" charset="-120"/>
               </a:rPr>
-              <a:t> bằng</a:t>
+              <a:t> nguồn.</a:t>
+            </a:r>
+            <a:r>
+              <a:rPr lang="en-US" sz="2550" dirty="0" spc="-9" kern="0">
+                <a:solidFill>
+                  <a:srgbClr val="14161C"/>
+                </a:solidFill>
+                <a:latin typeface="Be Vietnam Pro" pitchFamily="34" charset="0"/>
+                <a:ea typeface="Be Vietnam Pro" pitchFamily="34" charset="-122"/>
+                <a:cs typeface="Be Vietnam Pro" pitchFamily="34" charset="-120"/>
+              </a:rPr>
+              <a:t> 720p,</a:t>
+            </a:r>
+            <a:r>
+              <a:rPr lang="en-US" sz="2550" dirty="0" spc="-1" kern="0">
+                <a:solidFill>
+                  <a:srgbClr val="14161C"/>
+                </a:solidFill>
+                <a:latin typeface="Be Vietnam Pro" pitchFamily="34" charset="0"/>
+                <a:ea typeface="Be Vietnam Pro" pitchFamily="34" charset="-122"/>
+                <a:cs typeface="Be Vietnam Pro" pitchFamily="34" charset="-120"/>
+              </a:rPr>
+              <a:t> 1080p,</a:t>
+            </a:r>
+            <a:r>
+              <a:rPr lang="en-US" sz="2550" dirty="0" spc="14" kern="0">
+                <a:solidFill>
+                  <a:srgbClr val="14161C"/>
+                </a:solidFill>
+                <a:latin typeface="Be Vietnam Pro" pitchFamily="34" charset="0"/>
+                <a:ea typeface="Be Vietnam Pro" pitchFamily="34" charset="-122"/>
+                <a:cs typeface="Be Vietnam Pro" pitchFamily="34" charset="-120"/>
+              </a:rPr>
+              <a:t> 4K</a:t>
+            </a:r>
+            <a:r>
+              <a:rPr lang="en-US" sz="2550" dirty="0" spc="1" kern="0">
+                <a:solidFill>
+                  <a:srgbClr val="14161C"/>
+                </a:solidFill>
+                <a:latin typeface="Be Vietnam Pro" pitchFamily="34" charset="0"/>
+                <a:ea typeface="Be Vietnam Pro" pitchFamily="34" charset="-122"/>
+                <a:cs typeface="Be Vietnam Pro" pitchFamily="34" charset="-120"/>
+              </a:rPr>
+              <a:t> là</a:t>
+            </a:r>
+            <a:r>
+              <a:rPr lang="en-US" sz="2550" dirty="0" spc="17" kern="0">
+                <a:solidFill>
+                  <a:srgbClr val="14161C"/>
+                </a:solidFill>
+                <a:latin typeface="Be Vietnam Pro" pitchFamily="34" charset="0"/>
+                <a:ea typeface="Be Vietnam Pro" pitchFamily="34" charset="-122"/>
+                <a:cs typeface="Be Vietnam Pro" pitchFamily="34" charset="-120"/>
+              </a:rPr>
+              <a:t> độ</a:t>
             </a:r>
             <a:r>
               <a:rPr lang="en-US" sz="2550" dirty="0" spc="0" kern="0">
@@ -5283,7 +5415,40 @@
                 <a:ea typeface="Be Vietnam Pro" pitchFamily="34" charset="-122"/>
                 <a:cs typeface="Be Vietnam Pro" pitchFamily="34" charset="-120"/>
               </a:rPr>
-              <a:t> phần</a:t>
+              <a:t> phân giải;</a:t>
+            </a:r>
+            <a:r>
+              <a:rPr lang="en-US" sz="2550" dirty="0" spc="-1" kern="0">
+                <a:solidFill>
+                  <a:srgbClr val="14161C"/>
+                </a:solidFill>
+                <a:latin typeface="Be Vietnam Pro" pitchFamily="34" charset="0"/>
+                <a:ea typeface="Be Vietnam Pro" pitchFamily="34" charset="-122"/>
+                <a:cs typeface="Be Vietnam Pro" pitchFamily="34" charset="-120"/>
+              </a:rPr>
+              <a:t> mỗi</a:t>
+            </a:r>
+            <a:r>
+              <a:rPr lang="en-US" sz="2550" dirty="0" spc="17" kern="0">
+                <a:solidFill>
+                  <a:srgbClr val="14161C"/>
+                </a:solidFill>
+                <a:latin typeface="Be Vietnam Pro" pitchFamily="34" charset="0"/>
+                <a:ea typeface="Be Vietnam Pro" pitchFamily="34" charset="-122"/>
+                <a:cs typeface="Be Vietnam Pro" pitchFamily="34" charset="-120"/>
+              </a:rPr>
+              <a:t> độ</a:t>
+            </a:r>
+            <a:r>
+              <a:rPr lang="en-US" sz="2550" dirty="0" spc="0" kern="0">
+                <a:solidFill>
+                  <a:srgbClr val="14161C"/>
+                </a:solidFill>
+                <a:latin typeface="Be Vietnam Pro" pitchFamily="34" charset="0"/>
+                <a:ea typeface="Be Vietnam Pro" pitchFamily="34" charset="-122"/>
+                <a:cs typeface="Be Vietnam Pro" pitchFamily="34" charset="-120"/>
+              </a:rPr>
+              <a:t> phân giải có</a:t>
             </a:r>
             <a:r>
               <a:rPr lang="en-US" sz="2550" dirty="0" spc="1" kern="0">
@@ -5294,7 +5459,7 @@
                 <a:ea typeface="Be Vietnam Pro" pitchFamily="34" charset="-122"/>
                 <a:cs typeface="Be Vietnam Pro" pitchFamily="34" charset="-120"/>
               </a:rPr>
-              <a:t> mềm thành</a:t>
+              <a:t> thể</a:t>
             </a:r>
             <a:r>
               <a:rPr lang="en-US" sz="2550" dirty="0" spc="0" kern="0">
@@ -5305,10 +5470,10 @@
                 <a:ea typeface="Be Vietnam Pro" pitchFamily="34" charset="-122"/>
                 <a:cs typeface="Be Vietnam Pro" pitchFamily="34" charset="-120"/>
               </a:rPr>
-              <a:t> chậm</a:t>
-            </a:r>
-            <a:r>
-              <a:rPr lang="en-US" sz="2550" dirty="0" spc="-18" kern="0">
+              <a:t> có</a:t>
+            </a:r>
+            <a:r>
+              <a:rPr lang="en-US" sz="2550" dirty="0" spc="1" kern="0">
                 <a:solidFill>
                   <a:srgbClr val="14161C"/>
                 </a:solidFill>
@@ -5316,10 +5481,10 @@
                 <a:ea typeface="Be Vietnam Pro" pitchFamily="34" charset="-122"/>
                 <a:cs typeface="Be Vietnam Pro" pitchFamily="34" charset="-120"/>
               </a:rPr>
-              <a:t> và</a:t>
-            </a:r>
-            <a:r>
-              <a:rPr lang="en-US" sz="2550" dirty="0" spc="-10" kern="0">
+              <a:t> nhiều</a:t>
+            </a:r>
+            <a:r>
+              <a:rPr lang="en-US" sz="2550" dirty="0" spc="-3" kern="0">
                 <a:solidFill>
                   <a:srgbClr val="14161C"/>
                 </a:solidFill>
@@ -5327,10 +5492,10 @@
                 <a:ea typeface="Be Vietnam Pro" pitchFamily="34" charset="-122"/>
                 <a:cs typeface="Be Vietnam Pro" pitchFamily="34" charset="-120"/>
               </a:rPr>
-              <a:t> tốn, nhất</a:t>
-            </a:r>
-            <a:r>
-              <a:rPr lang="en-US" sz="2550" dirty="0" spc="1" kern="0">
+              <a:t> bản</a:t>
+            </a:r>
+            <a:r>
+              <a:rPr lang="en-US" sz="2550" dirty="0" spc="0" kern="0">
                 <a:solidFill>
                   <a:srgbClr val="14161C"/>
                 </a:solidFill>
@@ -5338,95 +5503,7 @@
                 <a:ea typeface="Be Vietnam Pro" pitchFamily="34" charset="-122"/>
                 <a:cs typeface="Be Vietnam Pro" pitchFamily="34" charset="-120"/>
               </a:rPr>
-              <a:t> là</a:t>
-            </a:r>
-            <a:r>
-              <a:rPr lang="en-US" sz="2550" dirty="0" spc="0" kern="0">
-                <a:solidFill>
-                  <a:srgbClr val="14161C"/>
-                </a:solidFill>
-                <a:latin typeface="Be Vietnam Pro" pitchFamily="34" charset="0"/>
-                <a:ea typeface="Be Vietnam Pro" pitchFamily="34" charset="-122"/>
-                <a:cs typeface="Be Vietnam Pro" pitchFamily="34" charset="-120"/>
-              </a:rPr>
-              <a:t> khi</a:t>
-            </a:r>
-            <a:r>
-              <a:rPr lang="en-US" sz="2550" dirty="0" spc="5" kern="0">
-                <a:solidFill>
-                  <a:srgbClr val="14161C"/>
-                </a:solidFill>
-                <a:latin typeface="Be Vietnam Pro" pitchFamily="34" charset="0"/>
-                <a:ea typeface="Be Vietnam Pro" pitchFamily="34" charset="-122"/>
-                <a:cs typeface="Be Vietnam Pro" pitchFamily="34" charset="-120"/>
-              </a:rPr>
-              <a:t> lượng</a:t>
-            </a:r>
-            <a:r>
-              <a:rPr lang="en-US" sz="2550" dirty="0" spc="-18" kern="0">
-                <a:solidFill>
-                  <a:srgbClr val="14161C"/>
-                </a:solidFill>
-                <a:latin typeface="Be Vietnam Pro" pitchFamily="34" charset="0"/>
-                <a:ea typeface="Be Vietnam Pro" pitchFamily="34" charset="-122"/>
-                <a:cs typeface="Be Vietnam Pro" pitchFamily="34" charset="-120"/>
-              </a:rPr>
-              <a:t> xem</a:t>
-            </a:r>
-            <a:r>
-              <a:rPr lang="en-US" sz="2550" dirty="0" spc="-9" kern="0">
-                <a:solidFill>
-                  <a:srgbClr val="14161C"/>
-                </a:solidFill>
-                <a:latin typeface="Be Vietnam Pro" pitchFamily="34" charset="0"/>
-                <a:ea typeface="Be Vietnam Pro" pitchFamily="34" charset="-122"/>
-                <a:cs typeface="Be Vietnam Pro" pitchFamily="34" charset="-120"/>
-              </a:rPr>
-              <a:t> tăng</a:t>
-            </a:r>
-            <a:r>
-              <a:rPr lang="en-US" sz="2550" dirty="0" spc="0" kern="0">
-                <a:solidFill>
-                  <a:srgbClr val="14161C"/>
-                </a:solidFill>
-                <a:latin typeface="Be Vietnam Pro" pitchFamily="34" charset="0"/>
-                <a:ea typeface="Be Vietnam Pro" pitchFamily="34" charset="-122"/>
-                <a:cs typeface="Be Vietnam Pro" pitchFamily="34" charset="-120"/>
-              </a:rPr>
-              <a:t> mạnh</a:t>
-            </a:r>
-            <a:r>
-              <a:rPr lang="en-US" sz="2550" dirty="0" spc="-16" kern="0">
-                <a:solidFill>
-                  <a:srgbClr val="14161C"/>
-                </a:solidFill>
-                <a:latin typeface="Be Vietnam Pro" pitchFamily="34" charset="0"/>
-                <a:ea typeface="Be Vietnam Pro" pitchFamily="34" charset="-122"/>
-                <a:cs typeface="Be Vietnam Pro" pitchFamily="34" charset="-120"/>
-              </a:rPr>
-              <a:t> trong</a:t>
-            </a:r>
-            <a:r>
-              <a:rPr lang="en-US" sz="2550" dirty="0" spc="13" kern="0">
-                <a:solidFill>
-                  <a:srgbClr val="14161C"/>
-                </a:solidFill>
-                <a:latin typeface="Be Vietnam Pro" pitchFamily="34" charset="0"/>
-                <a:ea typeface="Be Vietnam Pro" pitchFamily="34" charset="-122"/>
-                <a:cs typeface="Be Vietnam Pro" pitchFamily="34" charset="-120"/>
-              </a:rPr>
-              <a:t> đại</a:t>
-            </a:r>
-            <a:r>
-              <a:rPr lang="en-US" sz="2550" dirty="0" spc="1" kern="0">
-                <a:solidFill>
-                  <a:srgbClr val="14161C"/>
-                </a:solidFill>
-                <a:latin typeface="Be Vietnam Pro" pitchFamily="34" charset="0"/>
-                <a:ea typeface="Be Vietnam Pro" pitchFamily="34" charset="-122"/>
-                <a:cs typeface="Be Vietnam Pro" pitchFamily="34" charset="-120"/>
-              </a:rPr>
-              <a:t> dịch.</a:t>
+              <a:t> nén.</a:t>
             </a:r>
             <a:endParaRPr lang="en-US" sz="2550" dirty="0"/>
           </a:p>
@@ -12152,7 +12229,7 @@
               <a:t>Một</a:t>
             </a:r>
             <a:r>
-              <a:rPr lang="en-US" sz="2850" dirty="0" spc="10" kern="0">
+              <a:rPr lang="en-US" sz="2850" dirty="0" spc="-4" kern="0">
                 <a:solidFill>
                   <a:srgbClr val="14161C"/>
                 </a:solidFill>
@@ -12160,7 +12237,7 @@
                 <a:ea typeface="Be Vietnam Pro" pitchFamily="34" charset="-122"/>
                 <a:cs typeface="Be Vietnam Pro" pitchFamily="34" charset="-120"/>
               </a:rPr>
-              <a:t> mức</a:t>
+              <a:t> bản</a:t>
             </a:r>
             <a:r>
               <a:rPr lang="en-US" sz="2850" dirty="0" spc="1" kern="0">
@@ -12356,7 +12433,7 @@
               <a:t> NHIỀU</a:t>
             </a:r>
             <a:r>
-              <a:rPr lang="en-US" sz="1950" b="1" spc="224" kern="0" dirty="0">
+              <a:rPr lang="en-US" sz="1950" b="1" spc="219" kern="0" dirty="0">
                 <a:solidFill>
                   <a:srgbClr val="F8D9D0"/>
                 </a:solidFill>
@@ -12364,7 +12441,7 @@
                 <a:ea typeface="Be Vietnam Pro" pitchFamily="34" charset="-122"/>
                 <a:cs typeface="Be Vietnam Pro" pitchFamily="34" charset="-120"/>
               </a:rPr>
-              <a:t> MỨC</a:t>
+              <a:t> BẢN</a:t>
             </a:r>
             <a:endParaRPr lang="en-US" sz="1950" dirty="0"/>
           </a:p>
@@ -12400,7 +12477,7 @@
               <a:buChar char="•"/>
             </a:pPr>
             <a:r>
-              <a:rPr lang="en-US" sz="2850" dirty="0" spc="-12" kern="0">
+              <a:rPr lang="en-US" sz="2850" dirty="0" spc="-3" kern="0">
                 <a:solidFill>
                   <a:srgbClr val="F3EEE3"/>
                 </a:solidFill>
@@ -12408,7 +12485,7 @@
                 <a:ea typeface="Be Vietnam Pro" pitchFamily="34" charset="-122"/>
                 <a:cs typeface="Be Vietnam Pro" pitchFamily="34" charset="-120"/>
               </a:rPr>
-              <a:t>720p</a:t>
+              <a:t>Bản</a:t>
             </a:r>
             <a:r>
               <a:rPr lang="en-US" sz="2850" dirty="0" spc="-1" kern="0">
@@ -12433,7 +12510,7 @@
               <a:t> cho</a:t>
             </a:r>
             <a:r>
-              <a:rPr lang="en-US" sz="2850" dirty="0" spc="23" kern="0">
+              <a:rPr lang="en-US" sz="2850" dirty="0" spc="-2" kern="0">
                 <a:solidFill>
                   <a:srgbClr val="F3EEE3"/>
                 </a:solidFill>
@@ -12441,10 +12518,10 @@
                 <a:ea typeface="Be Vietnam Pro" pitchFamily="34" charset="-122"/>
                 <a:cs typeface="Be Vietnam Pro" pitchFamily="34" charset="-120"/>
               </a:rPr>
-              <a:t> điện</a:t>
-            </a:r>
-            <a:r>
-              <a:rPr lang="en-US" sz="2850" dirty="0" spc="-1" kern="0">
+              <a:t> mạng</a:t>
+            </a:r>
+            <a:r>
+              <a:rPr lang="en-US" sz="2850" dirty="0" spc="-19" kern="0">
                 <a:solidFill>
                   <a:srgbClr val="F3EEE3"/>
                 </a:solidFill>
@@ -12452,7 +12529,7 @@
                 <a:ea typeface="Be Vietnam Pro" pitchFamily="34" charset="-122"/>
                 <a:cs typeface="Be Vietnam Pro" pitchFamily="34" charset="-120"/>
               </a:rPr>
-              <a:t> thoại.</a:t>
+              <a:t> yếu.</a:t>
             </a:r>
             <a:endParaRPr lang="en-US" sz="2850" dirty="0"/>
           </a:p>
@@ -12466,7 +12543,7 @@
               <a:buChar char="•"/>
             </a:pPr>
             <a:r>
-              <a:rPr lang="en-US" sz="2850" dirty="0" spc="27" kern="0">
+              <a:rPr lang="en-US" sz="2850" dirty="0" spc="-3" kern="0">
                 <a:solidFill>
                   <a:srgbClr val="F3EEE3"/>
                 </a:solidFill>
@@ -12474,10 +12551,10 @@
                 <a:ea typeface="Be Vietnam Pro" pitchFamily="34" charset="-122"/>
                 <a:cs typeface="Be Vietnam Pro" pitchFamily="34" charset="-120"/>
               </a:rPr>
-              <a:t>4K</a:t>
-            </a:r>
-            <a:r>
-              <a:rPr lang="en-US" sz="2850" dirty="0" spc="1" kern="0">
+              <a:t>Bản</a:t>
+            </a:r>
+            <a:r>
+              <a:rPr lang="en-US" sz="2850" dirty="0" spc="-9" kern="0">
                 <a:solidFill>
                   <a:srgbClr val="F3EEE3"/>
                 </a:solidFill>
@@ -12485,10 +12562,21 @@
                 <a:ea typeface="Be Vietnam Pro" pitchFamily="34" charset="-122"/>
                 <a:cs typeface="Be Vietnam Pro" pitchFamily="34" charset="-120"/>
               </a:rPr>
+              <a:t> nét</a:t>
+            </a:r>
+            <a:r>
+              <a:rPr lang="en-US" sz="2850" dirty="0" spc="2" kern="0">
+                <a:solidFill>
+                  <a:srgbClr val="F3EEE3"/>
+                </a:solidFill>
+                <a:latin typeface="Be Vietnam Pro" pitchFamily="34" charset="0"/>
+                <a:ea typeface="Be Vietnam Pro" pitchFamily="34" charset="-122"/>
+                <a:cs typeface="Be Vietnam Pro" pitchFamily="34" charset="-120"/>
+              </a:rPr>
               <a:t> cho</a:t>
             </a:r>
             <a:r>
-              <a:rPr lang="en-US" sz="2850" dirty="0" spc="-1" kern="0">
+              <a:rPr lang="en-US" sz="2850" dirty="0" spc="-2" kern="0">
                 <a:solidFill>
                   <a:srgbClr val="F3EEE3"/>
                 </a:solidFill>

</xml_diff>